<commit_message>
Wording: headings, slide titles and table cells follow the style rules; slides 15, 22, 38, 47, 49, 50 and 56 and the Word templates updated
</commit_message>
<xml_diff>
--- a/deck/slides/the-ai-control-plane-slide-15.pptx
+++ b/deck/slides/the-ai-control-plane-slide-15.pptx
@@ -1084,7 +1084,7 @@
                 <a:ea typeface="Plus Jakarta Sans" pitchFamily="34" charset="-122"/>
                 <a:cs typeface="Plus Jakarta Sans" pitchFamily="34" charset="-120"/>
               </a:rPr>
-              <a:t>Tiers that travel, and move in both directions</a:t>
+              <a:t>Tiers that travel and move in both directions</a:t>
             </a:r>
             <a:endParaRPr lang="en-US" sz="2600" dirty="0"/>
           </a:p>
@@ -1517,7 +1517,28 @@
                           <a:ea typeface="Plus Jakarta Sans" pitchFamily="34" charset="-122"/>
                           <a:cs typeface="Plus Jakarta Sans" pitchFamily="34" charset="-120"/>
                         </a:rPr>
-                        <a:t>Scope 1, No Agency (read-only); Scope 2, Prescribed Agency</a:t>
+                        <a:t>Scope 1, No Agency (read-only)</a:t>
+                      </a:r>
+                      <a:endParaRPr lang="en-US" sz="1000" dirty="0">
+                        <a:latin typeface="Plus Jakarta Sans" charset="0"/>
+                        <a:ea typeface="Plus Jakarta Sans" charset="0"/>
+                        <a:cs typeface="Plus Jakarta Sans" charset="0"/>
+                      </a:endParaRPr>
+                    </a:p>
+                    <a:p>
+                      <a:pPr indent="0" marL="0">
+                        <a:buNone/>
+                      </a:pPr>
+                      <a:r>
+                        <a:rPr lang="en-US" sz="1000" dirty="0">
+                          <a:solidFill>
+                            <a:srgbClr val="334155"/>
+                          </a:solidFill>
+                          <a:latin typeface="Plus Jakarta Sans" pitchFamily="34" charset="0"/>
+                          <a:ea typeface="Plus Jakarta Sans" pitchFamily="34" charset="-122"/>
+                          <a:cs typeface="Plus Jakarta Sans" pitchFamily="34" charset="-120"/>
+                        </a:rPr>
+                        <a:t>Scope 2, Prescribed Agency</a:t>
                       </a:r>
                       <a:endParaRPr lang="en-US" sz="1000" dirty="0">
                         <a:latin typeface="Plus Jakarta Sans" charset="0"/>
@@ -1585,7 +1606,28 @@
                           <a:ea typeface="Plus Jakarta Sans" pitchFamily="34" charset="-122"/>
                           <a:cs typeface="Plus Jakarta Sans" pitchFamily="34" charset="-120"/>
                         </a:rPr>
-                        <a:t>Shadow; supervised</a:t>
+                        <a:t>Shadow</a:t>
+                      </a:r>
+                      <a:endParaRPr lang="en-US" sz="1000" dirty="0">
+                        <a:latin typeface="Plus Jakarta Sans" charset="0"/>
+                        <a:ea typeface="Plus Jakarta Sans" charset="0"/>
+                        <a:cs typeface="Plus Jakarta Sans" charset="0"/>
+                      </a:endParaRPr>
+                    </a:p>
+                    <a:p>
+                      <a:pPr indent="0" marL="0">
+                        <a:buNone/>
+                      </a:pPr>
+                      <a:r>
+                        <a:rPr lang="en-US" sz="1000" dirty="0">
+                          <a:solidFill>
+                            <a:srgbClr val="334155"/>
+                          </a:solidFill>
+                          <a:latin typeface="Plus Jakarta Sans" pitchFamily="34" charset="0"/>
+                          <a:ea typeface="Plus Jakarta Sans" pitchFamily="34" charset="-122"/>
+                          <a:cs typeface="Plus Jakarta Sans" pitchFamily="34" charset="-120"/>
+                        </a:rPr>
+                        <a:t>Supervised</a:t>
                       </a:r>
                       <a:endParaRPr lang="en-US" sz="1000" dirty="0">
                         <a:latin typeface="Plus Jakarta Sans" charset="0"/>
@@ -1653,7 +1695,28 @@
                           <a:ea typeface="Plus Jakarta Sans" pitchFamily="34" charset="-122"/>
                           <a:cs typeface="Plus Jakarta Sans" pitchFamily="34" charset="-120"/>
                         </a:rPr>
-                        <a:t>Taskers; collaborators</a:t>
+                        <a:t>Taskers</a:t>
+                      </a:r>
+                      <a:endParaRPr lang="en-US" sz="1000" dirty="0">
+                        <a:latin typeface="Plus Jakarta Sans" charset="0"/>
+                        <a:ea typeface="Plus Jakarta Sans" charset="0"/>
+                        <a:cs typeface="Plus Jakarta Sans" charset="0"/>
+                      </a:endParaRPr>
+                    </a:p>
+                    <a:p>
+                      <a:pPr indent="0" marL="0">
+                        <a:buNone/>
+                      </a:pPr>
+                      <a:r>
+                        <a:rPr lang="en-US" sz="1000" dirty="0">
+                          <a:solidFill>
+                            <a:srgbClr val="334155"/>
+                          </a:solidFill>
+                          <a:latin typeface="Plus Jakarta Sans" pitchFamily="34" charset="0"/>
+                          <a:ea typeface="Plus Jakarta Sans" pitchFamily="34" charset="-122"/>
+                          <a:cs typeface="Plus Jakarta Sans" pitchFamily="34" charset="-120"/>
+                        </a:rPr>
+                        <a:t>Collaborators</a:t>
                       </a:r>
                       <a:endParaRPr lang="en-US" sz="1000" dirty="0">
                         <a:latin typeface="Plus Jakarta Sans" charset="0"/>
@@ -1859,7 +1922,28 @@
                           <a:ea typeface="Plus Jakarta Sans" pitchFamily="34" charset="-122"/>
                           <a:cs typeface="Plus Jakarta Sans" pitchFamily="34" charset="-120"/>
                         </a:rPr>
-                        <a:t>Supervised; guided autonomy</a:t>
+                        <a:t>Supervised</a:t>
+                      </a:r>
+                      <a:endParaRPr lang="en-US" sz="1000" dirty="0">
+                        <a:latin typeface="Plus Jakarta Sans" charset="0"/>
+                        <a:ea typeface="Plus Jakarta Sans" charset="0"/>
+                        <a:cs typeface="Plus Jakarta Sans" charset="0"/>
+                      </a:endParaRPr>
+                    </a:p>
+                    <a:p>
+                      <a:pPr indent="0" marL="0">
+                        <a:buNone/>
+                      </a:pPr>
+                      <a:r>
+                        <a:rPr lang="en-US" sz="1000" dirty="0">
+                          <a:solidFill>
+                            <a:srgbClr val="334155"/>
+                          </a:solidFill>
+                          <a:latin typeface="Plus Jakarta Sans" pitchFamily="34" charset="0"/>
+                          <a:ea typeface="Plus Jakarta Sans" pitchFamily="34" charset="-122"/>
+                          <a:cs typeface="Plus Jakarta Sans" pitchFamily="34" charset="-120"/>
+                        </a:rPr>
+                        <a:t>Guided autonomy</a:t>
                       </a:r>
                       <a:endParaRPr lang="en-US" sz="1000" dirty="0">
                         <a:latin typeface="Plus Jakarta Sans" charset="0"/>
@@ -1927,7 +2011,28 @@
                           <a:ea typeface="Plus Jakarta Sans" pitchFamily="34" charset="-122"/>
                           <a:cs typeface="Plus Jakarta Sans" pitchFamily="34" charset="-120"/>
                         </a:rPr>
-                        <a:t>Taskers; automators</a:t>
+                        <a:t>Taskers</a:t>
+                      </a:r>
+                      <a:endParaRPr lang="en-US" sz="1000" dirty="0">
+                        <a:latin typeface="Plus Jakarta Sans" charset="0"/>
+                        <a:ea typeface="Plus Jakarta Sans" charset="0"/>
+                        <a:cs typeface="Plus Jakarta Sans" charset="0"/>
+                      </a:endParaRPr>
+                    </a:p>
+                    <a:p>
+                      <a:pPr indent="0" marL="0">
+                        <a:buNone/>
+                      </a:pPr>
+                      <a:r>
+                        <a:rPr lang="en-US" sz="1000" dirty="0">
+                          <a:solidFill>
+                            <a:srgbClr val="334155"/>
+                          </a:solidFill>
+                          <a:latin typeface="Plus Jakarta Sans" pitchFamily="34" charset="0"/>
+                          <a:ea typeface="Plus Jakarta Sans" pitchFamily="34" charset="-122"/>
+                          <a:cs typeface="Plus Jakarta Sans" pitchFamily="34" charset="-120"/>
+                        </a:rPr>
+                        <a:t>Automators</a:t>
                       </a:r>
                       <a:endParaRPr lang="en-US" sz="1000" dirty="0">
                         <a:latin typeface="Plus Jakarta Sans" charset="0"/>
@@ -3091,7 +3196,7 @@
                 <a:ea typeface="Plus Jakarta Sans" pitchFamily="34" charset="-122"/>
                 <a:cs typeface="Plus Jakarta Sans" pitchFamily="34" charset="-120"/>
               </a:rPr>
-              <a:t>DELEGATION CHAINS: NARROW AUTHORITY AT EVERY HOP</a:t>
+              <a:t>NARROW AUTHORITY AT EVERY HOP OF A DELEGATION CHAIN</a:t>
             </a:r>
             <a:endParaRPr lang="en-US" sz="1000" dirty="0"/>
           </a:p>

</xml_diff>